<commit_message>
ejercicios 1 al 14
</commit_message>
<xml_diff>
--- a/pizarra.pptx
+++ b/pizarra.pptx
@@ -8,6 +8,8 @@
     <p:sldId id="256" r:id="rId2"/>
     <p:sldId id="257" r:id="rId3"/>
     <p:sldId id="258" r:id="rId4"/>
+    <p:sldId id="259" r:id="rId5"/>
+    <p:sldId id="260" r:id="rId6"/>
   </p:sldIdLst>
   <p:sldSz cx="9144000" cy="6858000" type="screen4x3"/>
   <p:notesSz cx="6858000" cy="9144000"/>
@@ -3640,6 +3642,886 @@
           </a:p>
         </p:txBody>
       </p:sp>
+    </p:spTree>
+  </p:cSld>
+  <p:clrMapOvr>
+    <a:masterClrMapping/>
+  </p:clrMapOvr>
+</p:sld>
+</file>
+
+<file path=ppt/slides/slide4.xml><?xml version="1.0" encoding="utf-8"?>
+<p:sld xmlns:a="http://schemas.openxmlformats.org/drawingml/2006/main" xmlns:r="http://schemas.openxmlformats.org/officeDocument/2006/relationships" xmlns:p="http://schemas.openxmlformats.org/presentationml/2006/main">
+  <p:cSld>
+    <p:spTree>
+      <p:nvGrpSpPr>
+        <p:cNvPr id="1" name=""/>
+        <p:cNvGrpSpPr/>
+        <p:nvPr/>
+      </p:nvGrpSpPr>
+      <p:grpSpPr>
+        <a:xfrm>
+          <a:off x="0" y="0"/>
+          <a:ext cx="0" cy="0"/>
+          <a:chOff x="0" y="0"/>
+          <a:chExt cx="0" cy="0"/>
+        </a:xfrm>
+      </p:grpSpPr>
+      <p:sp>
+        <p:nvSpPr>
+          <p:cNvPr id="2" name="1 CuadroTexto"/>
+          <p:cNvSpPr txBox="1"/>
+          <p:nvPr/>
+        </p:nvSpPr>
+        <p:spPr>
+          <a:xfrm>
+            <a:off x="755576" y="1628800"/>
+            <a:ext cx="6048672" cy="923330"/>
+          </a:xfrm>
+          <a:prstGeom prst="rect">
+            <a:avLst/>
+          </a:prstGeom>
+          <a:noFill/>
+        </p:spPr>
+        <p:txBody>
+          <a:bodyPr wrap="square" rtlCol="0">
+            <a:spAutoFit/>
+          </a:bodyPr>
+          <a:lstStyle/>
+          <a:p>
+            <a:r>
+              <a:rPr lang="es-ES" dirty="0" err="1" smtClean="0"/>
+              <a:t>void</a:t>
+            </a:r>
+            <a:r>
+              <a:rPr lang="es-ES" dirty="0" smtClean="0"/>
+              <a:t> suma(</a:t>
+            </a:r>
+            <a:r>
+              <a:rPr lang="es-ES" dirty="0" err="1" smtClean="0"/>
+              <a:t>int</a:t>
+            </a:r>
+            <a:r>
+              <a:rPr lang="es-ES" dirty="0" smtClean="0"/>
+              <a:t> a){</a:t>
+            </a:r>
+          </a:p>
+          <a:p>
+            <a:r>
+              <a:rPr lang="es-ES" dirty="0" smtClean="0"/>
+              <a:t>	a=a+2;</a:t>
+            </a:r>
+            <a:endParaRPr lang="es-ES" dirty="0" smtClean="0"/>
+          </a:p>
+          <a:p>
+            <a:r>
+              <a:rPr lang="es-ES" dirty="0" smtClean="0"/>
+              <a:t>}</a:t>
+            </a:r>
+            <a:endParaRPr lang="es-ES" dirty="0"/>
+          </a:p>
+        </p:txBody>
+      </p:sp>
+      <p:sp>
+        <p:nvSpPr>
+          <p:cNvPr id="3" name="2 CuadroTexto"/>
+          <p:cNvSpPr txBox="1"/>
+          <p:nvPr/>
+        </p:nvSpPr>
+        <p:spPr>
+          <a:xfrm>
+            <a:off x="827584" y="3645024"/>
+            <a:ext cx="3888432" cy="923330"/>
+          </a:xfrm>
+          <a:prstGeom prst="rect">
+            <a:avLst/>
+          </a:prstGeom>
+          <a:noFill/>
+        </p:spPr>
+        <p:txBody>
+          <a:bodyPr wrap="square" rtlCol="0">
+            <a:spAutoFit/>
+          </a:bodyPr>
+          <a:lstStyle/>
+          <a:p>
+            <a:r>
+              <a:rPr lang="es-ES" dirty="0" err="1" smtClean="0"/>
+              <a:t>int</a:t>
+            </a:r>
+            <a:r>
+              <a:rPr lang="es-ES" dirty="0" smtClean="0"/>
+              <a:t> x=10;</a:t>
+            </a:r>
+          </a:p>
+          <a:p>
+            <a:r>
+              <a:rPr lang="es-ES" dirty="0" smtClean="0"/>
+              <a:t>suma(x);</a:t>
+            </a:r>
+          </a:p>
+          <a:p>
+            <a:r>
+              <a:rPr lang="es-ES" dirty="0" err="1" smtClean="0"/>
+              <a:t>System.out.println</a:t>
+            </a:r>
+            <a:r>
+              <a:rPr lang="es-ES" dirty="0" smtClean="0"/>
+              <a:t>(x); //10</a:t>
+            </a:r>
+            <a:endParaRPr lang="es-ES" dirty="0"/>
+          </a:p>
+        </p:txBody>
+      </p:sp>
+      <p:sp>
+        <p:nvSpPr>
+          <p:cNvPr id="4" name="3 Rectángulo"/>
+          <p:cNvSpPr/>
+          <p:nvPr/>
+        </p:nvSpPr>
+        <p:spPr>
+          <a:xfrm>
+            <a:off x="3491880" y="1700808"/>
+            <a:ext cx="1008112" cy="288032"/>
+          </a:xfrm>
+          <a:prstGeom prst="rect">
+            <a:avLst/>
+          </a:prstGeom>
+          <a:noFill/>
+        </p:spPr>
+        <p:style>
+          <a:lnRef idx="2">
+            <a:schemeClr val="accent1">
+              <a:shade val="50000"/>
+            </a:schemeClr>
+          </a:lnRef>
+          <a:fillRef idx="1">
+            <a:schemeClr val="accent1"/>
+          </a:fillRef>
+          <a:effectRef idx="0">
+            <a:schemeClr val="accent1"/>
+          </a:effectRef>
+          <a:fontRef idx="minor">
+            <a:schemeClr val="lt1"/>
+          </a:fontRef>
+        </p:style>
+        <p:txBody>
+          <a:bodyPr rtlCol="0" anchor="ctr"/>
+          <a:lstStyle/>
+          <a:p>
+            <a:pPr algn="ctr"/>
+            <a:endParaRPr lang="es-ES"/>
+          </a:p>
+        </p:txBody>
+      </p:sp>
+      <p:sp>
+        <p:nvSpPr>
+          <p:cNvPr id="5" name="4 CuadroTexto"/>
+          <p:cNvSpPr txBox="1"/>
+          <p:nvPr/>
+        </p:nvSpPr>
+        <p:spPr>
+          <a:xfrm>
+            <a:off x="3131840" y="1700808"/>
+            <a:ext cx="216024" cy="369332"/>
+          </a:xfrm>
+          <a:prstGeom prst="rect">
+            <a:avLst/>
+          </a:prstGeom>
+          <a:noFill/>
+        </p:spPr>
+        <p:txBody>
+          <a:bodyPr wrap="square" rtlCol="0">
+            <a:spAutoFit/>
+          </a:bodyPr>
+          <a:lstStyle/>
+          <a:p>
+            <a:r>
+              <a:rPr lang="es-ES" dirty="0" smtClean="0"/>
+              <a:t>a</a:t>
+            </a:r>
+            <a:endParaRPr lang="es-ES" dirty="0"/>
+          </a:p>
+        </p:txBody>
+      </p:sp>
+      <p:sp>
+        <p:nvSpPr>
+          <p:cNvPr id="6" name="5 Rectángulo"/>
+          <p:cNvSpPr/>
+          <p:nvPr/>
+        </p:nvSpPr>
+        <p:spPr>
+          <a:xfrm>
+            <a:off x="4283968" y="4077072"/>
+            <a:ext cx="1008112" cy="288032"/>
+          </a:xfrm>
+          <a:prstGeom prst="rect">
+            <a:avLst/>
+          </a:prstGeom>
+          <a:noFill/>
+        </p:spPr>
+        <p:style>
+          <a:lnRef idx="2">
+            <a:schemeClr val="accent1">
+              <a:shade val="50000"/>
+            </a:schemeClr>
+          </a:lnRef>
+          <a:fillRef idx="1">
+            <a:schemeClr val="accent1"/>
+          </a:fillRef>
+          <a:effectRef idx="0">
+            <a:schemeClr val="accent1"/>
+          </a:effectRef>
+          <a:fontRef idx="minor">
+            <a:schemeClr val="lt1"/>
+          </a:fontRef>
+        </p:style>
+        <p:txBody>
+          <a:bodyPr rtlCol="0" anchor="ctr"/>
+          <a:lstStyle/>
+          <a:p>
+            <a:pPr algn="ctr"/>
+            <a:endParaRPr lang="es-ES"/>
+          </a:p>
+        </p:txBody>
+      </p:sp>
+      <p:sp>
+        <p:nvSpPr>
+          <p:cNvPr id="7" name="6 CuadroTexto"/>
+          <p:cNvSpPr txBox="1"/>
+          <p:nvPr/>
+        </p:nvSpPr>
+        <p:spPr>
+          <a:xfrm>
+            <a:off x="3923928" y="4077072"/>
+            <a:ext cx="216024" cy="369332"/>
+          </a:xfrm>
+          <a:prstGeom prst="rect">
+            <a:avLst/>
+          </a:prstGeom>
+          <a:noFill/>
+        </p:spPr>
+        <p:txBody>
+          <a:bodyPr wrap="square" rtlCol="0">
+            <a:spAutoFit/>
+          </a:bodyPr>
+          <a:lstStyle/>
+          <a:p>
+            <a:r>
+              <a:rPr lang="es-ES" dirty="0" smtClean="0"/>
+              <a:t>x</a:t>
+            </a:r>
+            <a:endParaRPr lang="es-ES" dirty="0"/>
+          </a:p>
+        </p:txBody>
+      </p:sp>
+      <p:sp>
+        <p:nvSpPr>
+          <p:cNvPr id="8" name="7 CuadroTexto"/>
+          <p:cNvSpPr txBox="1"/>
+          <p:nvPr/>
+        </p:nvSpPr>
+        <p:spPr>
+          <a:xfrm>
+            <a:off x="4427984" y="4077072"/>
+            <a:ext cx="720080" cy="369332"/>
+          </a:xfrm>
+          <a:prstGeom prst="rect">
+            <a:avLst/>
+          </a:prstGeom>
+          <a:noFill/>
+        </p:spPr>
+        <p:txBody>
+          <a:bodyPr wrap="square" rtlCol="0">
+            <a:spAutoFit/>
+          </a:bodyPr>
+          <a:lstStyle/>
+          <a:p>
+            <a:r>
+              <a:rPr lang="es-ES" dirty="0" smtClean="0"/>
+              <a:t>10</a:t>
+            </a:r>
+            <a:endParaRPr lang="es-ES" dirty="0"/>
+          </a:p>
+        </p:txBody>
+      </p:sp>
+      <p:cxnSp>
+        <p:nvCxnSpPr>
+          <p:cNvPr id="10" name="9 Conector recto de flecha"/>
+          <p:cNvCxnSpPr/>
+          <p:nvPr/>
+        </p:nvCxnSpPr>
+        <p:spPr>
+          <a:xfrm flipH="1" flipV="1">
+            <a:off x="3923928" y="1916832"/>
+            <a:ext cx="720080" cy="2304256"/>
+          </a:xfrm>
+          <a:prstGeom prst="straightConnector1">
+            <a:avLst/>
+          </a:prstGeom>
+          <a:ln>
+            <a:tailEnd type="arrow"/>
+          </a:ln>
+        </p:spPr>
+        <p:style>
+          <a:lnRef idx="1">
+            <a:schemeClr val="accent1"/>
+          </a:lnRef>
+          <a:fillRef idx="0">
+            <a:schemeClr val="accent1"/>
+          </a:fillRef>
+          <a:effectRef idx="0">
+            <a:schemeClr val="accent1"/>
+          </a:effectRef>
+          <a:fontRef idx="minor">
+            <a:schemeClr val="tx1"/>
+          </a:fontRef>
+        </p:style>
+      </p:cxnSp>
+      <p:sp>
+        <p:nvSpPr>
+          <p:cNvPr id="11" name="10 CuadroTexto"/>
+          <p:cNvSpPr txBox="1"/>
+          <p:nvPr/>
+        </p:nvSpPr>
+        <p:spPr>
+          <a:xfrm>
+            <a:off x="3851920" y="1628800"/>
+            <a:ext cx="720080" cy="369332"/>
+          </a:xfrm>
+          <a:prstGeom prst="rect">
+            <a:avLst/>
+          </a:prstGeom>
+          <a:noFill/>
+        </p:spPr>
+        <p:txBody>
+          <a:bodyPr wrap="square" rtlCol="0">
+            <a:spAutoFit/>
+          </a:bodyPr>
+          <a:lstStyle/>
+          <a:p>
+            <a:r>
+              <a:rPr lang="es-ES" dirty="0" smtClean="0"/>
+              <a:t>12</a:t>
+            </a:r>
+            <a:endParaRPr lang="es-ES" dirty="0"/>
+          </a:p>
+        </p:txBody>
+      </p:sp>
+    </p:spTree>
+  </p:cSld>
+  <p:clrMapOvr>
+    <a:masterClrMapping/>
+  </p:clrMapOvr>
+</p:sld>
+</file>
+
+<file path=ppt/slides/slide5.xml><?xml version="1.0" encoding="utf-8"?>
+<p:sld xmlns:a="http://schemas.openxmlformats.org/drawingml/2006/main" xmlns:r="http://schemas.openxmlformats.org/officeDocument/2006/relationships" xmlns:p="http://schemas.openxmlformats.org/presentationml/2006/main">
+  <p:cSld>
+    <p:spTree>
+      <p:nvGrpSpPr>
+        <p:cNvPr id="1" name=""/>
+        <p:cNvGrpSpPr/>
+        <p:nvPr/>
+      </p:nvGrpSpPr>
+      <p:grpSpPr>
+        <a:xfrm>
+          <a:off x="0" y="0"/>
+          <a:ext cx="0" cy="0"/>
+          <a:chOff x="0" y="0"/>
+          <a:chExt cx="0" cy="0"/>
+        </a:xfrm>
+      </p:grpSpPr>
+      <p:sp>
+        <p:nvSpPr>
+          <p:cNvPr id="2" name="1 CuadroTexto"/>
+          <p:cNvSpPr txBox="1"/>
+          <p:nvPr/>
+        </p:nvSpPr>
+        <p:spPr>
+          <a:xfrm>
+            <a:off x="755576" y="1628800"/>
+            <a:ext cx="6048672" cy="923330"/>
+          </a:xfrm>
+          <a:prstGeom prst="rect">
+            <a:avLst/>
+          </a:prstGeom>
+          <a:noFill/>
+        </p:spPr>
+        <p:txBody>
+          <a:bodyPr wrap="square" rtlCol="0">
+            <a:spAutoFit/>
+          </a:bodyPr>
+          <a:lstStyle/>
+          <a:p>
+            <a:r>
+              <a:rPr lang="es-ES" dirty="0" err="1" smtClean="0"/>
+              <a:t>void</a:t>
+            </a:r>
+            <a:r>
+              <a:rPr lang="es-ES" dirty="0" smtClean="0"/>
+              <a:t> suma(</a:t>
+            </a:r>
+            <a:r>
+              <a:rPr lang="es-ES" dirty="0" err="1" smtClean="0"/>
+              <a:t>int</a:t>
+            </a:r>
+            <a:r>
+              <a:rPr lang="es-ES" dirty="0" smtClean="0"/>
+              <a:t>[] a){</a:t>
+            </a:r>
+          </a:p>
+          <a:p>
+            <a:r>
+              <a:rPr lang="es-ES" dirty="0" smtClean="0"/>
+              <a:t>	a[0]=a[0]+2;</a:t>
+            </a:r>
+            <a:endParaRPr lang="es-ES" dirty="0" smtClean="0"/>
+          </a:p>
+          <a:p>
+            <a:r>
+              <a:rPr lang="es-ES" dirty="0" smtClean="0"/>
+              <a:t>}</a:t>
+            </a:r>
+            <a:endParaRPr lang="es-ES" dirty="0"/>
+          </a:p>
+        </p:txBody>
+      </p:sp>
+      <p:sp>
+        <p:nvSpPr>
+          <p:cNvPr id="3" name="2 CuadroTexto"/>
+          <p:cNvSpPr txBox="1"/>
+          <p:nvPr/>
+        </p:nvSpPr>
+        <p:spPr>
+          <a:xfrm>
+            <a:off x="827584" y="3645024"/>
+            <a:ext cx="3888432" cy="923330"/>
+          </a:xfrm>
+          <a:prstGeom prst="rect">
+            <a:avLst/>
+          </a:prstGeom>
+          <a:noFill/>
+        </p:spPr>
+        <p:txBody>
+          <a:bodyPr wrap="square" rtlCol="0">
+            <a:spAutoFit/>
+          </a:bodyPr>
+          <a:lstStyle/>
+          <a:p>
+            <a:r>
+              <a:rPr lang="es-ES" dirty="0" err="1" smtClean="0"/>
+              <a:t>int</a:t>
+            </a:r>
+            <a:r>
+              <a:rPr lang="es-ES" dirty="0" smtClean="0"/>
+              <a:t> [] x={10};</a:t>
+            </a:r>
+          </a:p>
+          <a:p>
+            <a:r>
+              <a:rPr lang="es-ES" dirty="0" smtClean="0"/>
+              <a:t>suma(x);</a:t>
+            </a:r>
+          </a:p>
+          <a:p>
+            <a:r>
+              <a:rPr lang="es-ES" dirty="0" err="1" smtClean="0"/>
+              <a:t>System.out.println</a:t>
+            </a:r>
+            <a:r>
+              <a:rPr lang="es-ES" dirty="0" smtClean="0"/>
+              <a:t>(x[0]); //12</a:t>
+            </a:r>
+            <a:endParaRPr lang="es-ES" dirty="0"/>
+          </a:p>
+        </p:txBody>
+      </p:sp>
+      <p:sp>
+        <p:nvSpPr>
+          <p:cNvPr id="4" name="3 Rectángulo"/>
+          <p:cNvSpPr/>
+          <p:nvPr/>
+        </p:nvSpPr>
+        <p:spPr>
+          <a:xfrm>
+            <a:off x="3491880" y="1700808"/>
+            <a:ext cx="1008112" cy="288032"/>
+          </a:xfrm>
+          <a:prstGeom prst="rect">
+            <a:avLst/>
+          </a:prstGeom>
+          <a:noFill/>
+        </p:spPr>
+        <p:style>
+          <a:lnRef idx="2">
+            <a:schemeClr val="accent1">
+              <a:shade val="50000"/>
+            </a:schemeClr>
+          </a:lnRef>
+          <a:fillRef idx="1">
+            <a:schemeClr val="accent1"/>
+          </a:fillRef>
+          <a:effectRef idx="0">
+            <a:schemeClr val="accent1"/>
+          </a:effectRef>
+          <a:fontRef idx="minor">
+            <a:schemeClr val="lt1"/>
+          </a:fontRef>
+        </p:style>
+        <p:txBody>
+          <a:bodyPr rtlCol="0" anchor="ctr"/>
+          <a:lstStyle/>
+          <a:p>
+            <a:pPr algn="ctr"/>
+            <a:endParaRPr lang="es-ES"/>
+          </a:p>
+        </p:txBody>
+      </p:sp>
+      <p:sp>
+        <p:nvSpPr>
+          <p:cNvPr id="5" name="4 CuadroTexto"/>
+          <p:cNvSpPr txBox="1"/>
+          <p:nvPr/>
+        </p:nvSpPr>
+        <p:spPr>
+          <a:xfrm>
+            <a:off x="3131840" y="1700808"/>
+            <a:ext cx="216024" cy="369332"/>
+          </a:xfrm>
+          <a:prstGeom prst="rect">
+            <a:avLst/>
+          </a:prstGeom>
+          <a:noFill/>
+        </p:spPr>
+        <p:txBody>
+          <a:bodyPr wrap="square" rtlCol="0">
+            <a:spAutoFit/>
+          </a:bodyPr>
+          <a:lstStyle/>
+          <a:p>
+            <a:r>
+              <a:rPr lang="es-ES" dirty="0" smtClean="0"/>
+              <a:t>a</a:t>
+            </a:r>
+            <a:endParaRPr lang="es-ES" dirty="0"/>
+          </a:p>
+        </p:txBody>
+      </p:sp>
+      <p:sp>
+        <p:nvSpPr>
+          <p:cNvPr id="6" name="5 Rectángulo"/>
+          <p:cNvSpPr/>
+          <p:nvPr/>
+        </p:nvSpPr>
+        <p:spPr>
+          <a:xfrm>
+            <a:off x="4283968" y="4077072"/>
+            <a:ext cx="1008112" cy="288032"/>
+          </a:xfrm>
+          <a:prstGeom prst="rect">
+            <a:avLst/>
+          </a:prstGeom>
+          <a:noFill/>
+        </p:spPr>
+        <p:style>
+          <a:lnRef idx="2">
+            <a:schemeClr val="accent1">
+              <a:shade val="50000"/>
+            </a:schemeClr>
+          </a:lnRef>
+          <a:fillRef idx="1">
+            <a:schemeClr val="accent1"/>
+          </a:fillRef>
+          <a:effectRef idx="0">
+            <a:schemeClr val="accent1"/>
+          </a:effectRef>
+          <a:fontRef idx="minor">
+            <a:schemeClr val="lt1"/>
+          </a:fontRef>
+        </p:style>
+        <p:txBody>
+          <a:bodyPr rtlCol="0" anchor="ctr"/>
+          <a:lstStyle/>
+          <a:p>
+            <a:pPr algn="ctr"/>
+            <a:endParaRPr lang="es-ES"/>
+          </a:p>
+        </p:txBody>
+      </p:sp>
+      <p:sp>
+        <p:nvSpPr>
+          <p:cNvPr id="7" name="6 CuadroTexto"/>
+          <p:cNvSpPr txBox="1"/>
+          <p:nvPr/>
+        </p:nvSpPr>
+        <p:spPr>
+          <a:xfrm>
+            <a:off x="3923928" y="4077072"/>
+            <a:ext cx="216024" cy="369332"/>
+          </a:xfrm>
+          <a:prstGeom prst="rect">
+            <a:avLst/>
+          </a:prstGeom>
+          <a:noFill/>
+        </p:spPr>
+        <p:txBody>
+          <a:bodyPr wrap="square" rtlCol="0">
+            <a:spAutoFit/>
+          </a:bodyPr>
+          <a:lstStyle/>
+          <a:p>
+            <a:r>
+              <a:rPr lang="es-ES" dirty="0" smtClean="0"/>
+              <a:t>x</a:t>
+            </a:r>
+            <a:endParaRPr lang="es-ES" dirty="0"/>
+          </a:p>
+        </p:txBody>
+      </p:sp>
+      <p:cxnSp>
+        <p:nvCxnSpPr>
+          <p:cNvPr id="13" name="12 Conector recto de flecha"/>
+          <p:cNvCxnSpPr/>
+          <p:nvPr/>
+        </p:nvCxnSpPr>
+        <p:spPr>
+          <a:xfrm>
+            <a:off x="4788024" y="4221088"/>
+            <a:ext cx="1440160" cy="576064"/>
+          </a:xfrm>
+          <a:prstGeom prst="straightConnector1">
+            <a:avLst/>
+          </a:prstGeom>
+          <a:ln>
+            <a:tailEnd type="arrow"/>
+          </a:ln>
+        </p:spPr>
+        <p:style>
+          <a:lnRef idx="1">
+            <a:schemeClr val="accent1"/>
+          </a:lnRef>
+          <a:fillRef idx="0">
+            <a:schemeClr val="accent1"/>
+          </a:fillRef>
+          <a:effectRef idx="0">
+            <a:schemeClr val="accent1"/>
+          </a:effectRef>
+          <a:fontRef idx="minor">
+            <a:schemeClr val="tx1"/>
+          </a:fontRef>
+        </p:style>
+      </p:cxnSp>
+      <p:sp>
+        <p:nvSpPr>
+          <p:cNvPr id="14" name="13 Elipse"/>
+          <p:cNvSpPr/>
+          <p:nvPr/>
+        </p:nvSpPr>
+        <p:spPr>
+          <a:xfrm>
+            <a:off x="6300192" y="4581128"/>
+            <a:ext cx="1224136" cy="504056"/>
+          </a:xfrm>
+          <a:prstGeom prst="ellipse">
+            <a:avLst/>
+          </a:prstGeom>
+        </p:spPr>
+        <p:style>
+          <a:lnRef idx="2">
+            <a:schemeClr val="accent1">
+              <a:shade val="50000"/>
+            </a:schemeClr>
+          </a:lnRef>
+          <a:fillRef idx="1">
+            <a:schemeClr val="accent1"/>
+          </a:fillRef>
+          <a:effectRef idx="0">
+            <a:schemeClr val="accent1"/>
+          </a:effectRef>
+          <a:fontRef idx="minor">
+            <a:schemeClr val="lt1"/>
+          </a:fontRef>
+        </p:style>
+        <p:txBody>
+          <a:bodyPr rtlCol="0" anchor="ctr"/>
+          <a:lstStyle/>
+          <a:p>
+            <a:pPr algn="ctr"/>
+            <a:endParaRPr lang="es-ES"/>
+          </a:p>
+        </p:txBody>
+      </p:sp>
+      <p:sp>
+        <p:nvSpPr>
+          <p:cNvPr id="15" name="14 Rectángulo"/>
+          <p:cNvSpPr/>
+          <p:nvPr/>
+        </p:nvSpPr>
+        <p:spPr>
+          <a:xfrm>
+            <a:off x="6516216" y="4725144"/>
+            <a:ext cx="936104" cy="216024"/>
+          </a:xfrm>
+          <a:prstGeom prst="rect">
+            <a:avLst/>
+          </a:prstGeom>
+        </p:spPr>
+        <p:style>
+          <a:lnRef idx="2">
+            <a:schemeClr val="accent1">
+              <a:shade val="50000"/>
+            </a:schemeClr>
+          </a:lnRef>
+          <a:fillRef idx="1">
+            <a:schemeClr val="accent1"/>
+          </a:fillRef>
+          <a:effectRef idx="0">
+            <a:schemeClr val="accent1"/>
+          </a:effectRef>
+          <a:fontRef idx="minor">
+            <a:schemeClr val="lt1"/>
+          </a:fontRef>
+        </p:style>
+        <p:txBody>
+          <a:bodyPr rtlCol="0" anchor="ctr"/>
+          <a:lstStyle/>
+          <a:p>
+            <a:pPr algn="ctr"/>
+            <a:endParaRPr lang="es-ES"/>
+          </a:p>
+        </p:txBody>
+      </p:sp>
+      <p:cxnSp>
+        <p:nvCxnSpPr>
+          <p:cNvPr id="17" name="16 Conector recto"/>
+          <p:cNvCxnSpPr/>
+          <p:nvPr/>
+        </p:nvCxnSpPr>
+        <p:spPr>
+          <a:xfrm>
+            <a:off x="6804248" y="4725144"/>
+            <a:ext cx="72008" cy="216024"/>
+          </a:xfrm>
+          <a:prstGeom prst="line">
+            <a:avLst/>
+          </a:prstGeom>
+        </p:spPr>
+        <p:style>
+          <a:lnRef idx="1">
+            <a:schemeClr val="accent1"/>
+          </a:lnRef>
+          <a:fillRef idx="0">
+            <a:schemeClr val="accent1"/>
+          </a:fillRef>
+          <a:effectRef idx="0">
+            <a:schemeClr val="accent1"/>
+          </a:effectRef>
+          <a:fontRef idx="minor">
+            <a:schemeClr val="tx1"/>
+          </a:fontRef>
+        </p:style>
+      </p:cxnSp>
+      <p:cxnSp>
+        <p:nvCxnSpPr>
+          <p:cNvPr id="19" name="18 Conector recto"/>
+          <p:cNvCxnSpPr/>
+          <p:nvPr/>
+        </p:nvCxnSpPr>
+        <p:spPr>
+          <a:xfrm>
+            <a:off x="7164288" y="4725144"/>
+            <a:ext cx="72008" cy="216024"/>
+          </a:xfrm>
+          <a:prstGeom prst="line">
+            <a:avLst/>
+          </a:prstGeom>
+        </p:spPr>
+        <p:style>
+          <a:lnRef idx="1">
+            <a:schemeClr val="accent1"/>
+          </a:lnRef>
+          <a:fillRef idx="0">
+            <a:schemeClr val="accent1"/>
+          </a:fillRef>
+          <a:effectRef idx="0">
+            <a:schemeClr val="accent1"/>
+          </a:effectRef>
+          <a:fontRef idx="minor">
+            <a:schemeClr val="tx1"/>
+          </a:fontRef>
+        </p:style>
+      </p:cxnSp>
+      <p:cxnSp>
+        <p:nvCxnSpPr>
+          <p:cNvPr id="21" name="20 Conector recto de flecha"/>
+          <p:cNvCxnSpPr>
+            <a:endCxn id="14" idx="1"/>
+          </p:cNvCxnSpPr>
+          <p:nvPr/>
+        </p:nvCxnSpPr>
+        <p:spPr>
+          <a:xfrm>
+            <a:off x="3923928" y="1844824"/>
+            <a:ext cx="2555535" cy="2810121"/>
+          </a:xfrm>
+          <a:prstGeom prst="straightConnector1">
+            <a:avLst/>
+          </a:prstGeom>
+          <a:ln>
+            <a:tailEnd type="arrow"/>
+          </a:ln>
+        </p:spPr>
+        <p:style>
+          <a:lnRef idx="1">
+            <a:schemeClr val="accent1"/>
+          </a:lnRef>
+          <a:fillRef idx="0">
+            <a:schemeClr val="accent1"/>
+          </a:fillRef>
+          <a:effectRef idx="0">
+            <a:schemeClr val="accent1"/>
+          </a:effectRef>
+          <a:fontRef idx="minor">
+            <a:schemeClr val="tx1"/>
+          </a:fontRef>
+        </p:style>
+      </p:cxnSp>
+      <p:cxnSp>
+        <p:nvCxnSpPr>
+          <p:cNvPr id="23" name="22 Conector recto de flecha"/>
+          <p:cNvCxnSpPr>
+            <a:endCxn id="4" idx="2"/>
+          </p:cNvCxnSpPr>
+          <p:nvPr/>
+        </p:nvCxnSpPr>
+        <p:spPr>
+          <a:xfrm flipH="1" flipV="1">
+            <a:off x="3995936" y="1988840"/>
+            <a:ext cx="648072" cy="2232248"/>
+          </a:xfrm>
+          <a:prstGeom prst="straightConnector1">
+            <a:avLst/>
+          </a:prstGeom>
+          <a:ln>
+            <a:tailEnd type="arrow"/>
+          </a:ln>
+        </p:spPr>
+        <p:style>
+          <a:lnRef idx="1">
+            <a:schemeClr val="accent1"/>
+          </a:lnRef>
+          <a:fillRef idx="0">
+            <a:schemeClr val="accent1"/>
+          </a:fillRef>
+          <a:effectRef idx="0">
+            <a:schemeClr val="accent1"/>
+          </a:effectRef>
+          <a:fontRef idx="minor">
+            <a:schemeClr val="tx1"/>
+          </a:fontRef>
+        </p:style>
+      </p:cxnSp>
     </p:spTree>
   </p:cSld>
   <p:clrMapOvr>

</xml_diff>

<commit_message>
proyectos 1 al 22
</commit_message>
<xml_diff>
--- a/pizarra.pptx
+++ b/pizarra.pptx
@@ -11,6 +11,7 @@
     <p:sldId id="259" r:id="rId5"/>
     <p:sldId id="260" r:id="rId6"/>
     <p:sldId id="261" r:id="rId7"/>
+    <p:sldId id="262" r:id="rId8"/>
   </p:sldIdLst>
   <p:sldSz cx="9144000" cy="6858000" type="screen4x3"/>
   <p:notesSz cx="6858000" cy="9144000"/>
@@ -4827,6 +4828,131 @@
           <a:p>
             <a:pPr algn="ctr"/>
             <a:endParaRPr lang="es-ES"/>
+          </a:p>
+        </p:txBody>
+      </p:sp>
+      <p:sp>
+        <p:nvSpPr>
+          <p:cNvPr id="11" name="10 Elipse"/>
+          <p:cNvSpPr/>
+          <p:nvPr/>
+        </p:nvSpPr>
+        <p:spPr>
+          <a:xfrm>
+            <a:off x="3635896" y="3861048"/>
+            <a:ext cx="720080" cy="504056"/>
+          </a:xfrm>
+          <a:prstGeom prst="ellipse">
+            <a:avLst/>
+          </a:prstGeom>
+        </p:spPr>
+        <p:style>
+          <a:lnRef idx="2">
+            <a:schemeClr val="accent1">
+              <a:shade val="50000"/>
+            </a:schemeClr>
+          </a:lnRef>
+          <a:fillRef idx="1">
+            <a:schemeClr val="accent1"/>
+          </a:fillRef>
+          <a:effectRef idx="0">
+            <a:schemeClr val="accent1"/>
+          </a:effectRef>
+          <a:fontRef idx="minor">
+            <a:schemeClr val="lt1"/>
+          </a:fontRef>
+        </p:style>
+        <p:txBody>
+          <a:bodyPr rtlCol="0" anchor="ctr"/>
+          <a:lstStyle/>
+          <a:p>
+            <a:pPr algn="ctr"/>
+            <a:endParaRPr lang="es-ES"/>
+          </a:p>
+        </p:txBody>
+      </p:sp>
+      <p:sp>
+        <p:nvSpPr>
+          <p:cNvPr id="12" name="11 CuadroTexto"/>
+          <p:cNvSpPr txBox="1"/>
+          <p:nvPr/>
+        </p:nvSpPr>
+        <p:spPr>
+          <a:xfrm>
+            <a:off x="4427984" y="3933056"/>
+            <a:ext cx="720080" cy="369332"/>
+          </a:xfrm>
+          <a:prstGeom prst="rect">
+            <a:avLst/>
+          </a:prstGeom>
+          <a:noFill/>
+        </p:spPr>
+        <p:txBody>
+          <a:bodyPr wrap="square" rtlCol="0">
+            <a:spAutoFit/>
+          </a:bodyPr>
+          <a:lstStyle/>
+          <a:p>
+            <a:r>
+              <a:rPr lang="es-ES" dirty="0" err="1" smtClean="0"/>
+              <a:t>DTOs</a:t>
+            </a:r>
+            <a:endParaRPr lang="es-ES" dirty="0"/>
+          </a:p>
+        </p:txBody>
+      </p:sp>
+    </p:spTree>
+  </p:cSld>
+  <p:clrMapOvr>
+    <a:masterClrMapping/>
+  </p:clrMapOvr>
+</p:sld>
+</file>
+
+<file path=ppt/slides/slide7.xml><?xml version="1.0" encoding="utf-8"?>
+<p:sld xmlns:a="http://schemas.openxmlformats.org/drawingml/2006/main" xmlns:r="http://schemas.openxmlformats.org/officeDocument/2006/relationships" xmlns:p="http://schemas.openxmlformats.org/presentationml/2006/main">
+  <p:cSld>
+    <p:spTree>
+      <p:nvGrpSpPr>
+        <p:cNvPr id="1" name=""/>
+        <p:cNvGrpSpPr/>
+        <p:nvPr/>
+      </p:nvGrpSpPr>
+      <p:grpSpPr>
+        <a:xfrm>
+          <a:off x="0" y="0"/>
+          <a:ext cx="0" cy="0"/>
+          <a:chOff x="0" y="0"/>
+          <a:chExt cx="0" cy="0"/>
+        </a:xfrm>
+      </p:grpSpPr>
+      <p:sp>
+        <p:nvSpPr>
+          <p:cNvPr id="2" name="1 CuadroTexto"/>
+          <p:cNvSpPr txBox="1"/>
+          <p:nvPr/>
+        </p:nvSpPr>
+        <p:spPr>
+          <a:xfrm>
+            <a:off x="2483768" y="980728"/>
+            <a:ext cx="1080120" cy="369332"/>
+          </a:xfrm>
+          <a:prstGeom prst="rect">
+            <a:avLst/>
+          </a:prstGeom>
+          <a:noFill/>
+        </p:spPr>
+        <p:txBody>
+          <a:bodyPr wrap="square" rtlCol="0">
+            <a:spAutoFit/>
+          </a:bodyPr>
+          <a:lstStyle/>
+          <a:p>
+            <a:r>
+              <a:rPr lang="es-ES" dirty="0" smtClean="0"/>
+              <a:t>JUNIT</a:t>
+            </a:r>
+            <a:endParaRPr lang="es-ES" dirty="0"/>
           </a:p>
         </p:txBody>
       </p:sp>

</xml_diff>

<commit_message>
proyectos 1 al 42
</commit_message>
<xml_diff>
--- a/pizarra.pptx
+++ b/pizarra.pptx
@@ -12,6 +12,7 @@
     <p:sldId id="260" r:id="rId6"/>
     <p:sldId id="261" r:id="rId7"/>
     <p:sldId id="262" r:id="rId8"/>
+    <p:sldId id="263" r:id="rId9"/>
   </p:sldIdLst>
   <p:sldSz cx="9144000" cy="6858000" type="screen4x3"/>
   <p:notesSz cx="6858000" cy="9144000"/>
@@ -295,7 +296,7 @@
             <a:fld id="{7A847CFC-816F-41D0-AAC0-9BF4FEBC753E}" type="datetimeFigureOut">
               <a:rPr lang="es-ES" smtClean="0"/>
               <a:pPr/>
-              <a:t>23/06/2026</a:t>
+              <a:t>26/06/2026</a:t>
             </a:fld>
             <a:endParaRPr lang="es-ES"/>
           </a:p>
@@ -462,7 +463,7 @@
             <a:fld id="{7A847CFC-816F-41D0-AAC0-9BF4FEBC753E}" type="datetimeFigureOut">
               <a:rPr lang="es-ES" smtClean="0"/>
               <a:pPr/>
-              <a:t>23/06/2026</a:t>
+              <a:t>26/06/2026</a:t>
             </a:fld>
             <a:endParaRPr lang="es-ES"/>
           </a:p>
@@ -639,7 +640,7 @@
             <a:fld id="{7A847CFC-816F-41D0-AAC0-9BF4FEBC753E}" type="datetimeFigureOut">
               <a:rPr lang="es-ES" smtClean="0"/>
               <a:pPr/>
-              <a:t>23/06/2026</a:t>
+              <a:t>26/06/2026</a:t>
             </a:fld>
             <a:endParaRPr lang="es-ES"/>
           </a:p>
@@ -806,7 +807,7 @@
             <a:fld id="{7A847CFC-816F-41D0-AAC0-9BF4FEBC753E}" type="datetimeFigureOut">
               <a:rPr lang="es-ES" smtClean="0"/>
               <a:pPr/>
-              <a:t>23/06/2026</a:t>
+              <a:t>26/06/2026</a:t>
             </a:fld>
             <a:endParaRPr lang="es-ES"/>
           </a:p>
@@ -1049,7 +1050,7 @@
             <a:fld id="{7A847CFC-816F-41D0-AAC0-9BF4FEBC753E}" type="datetimeFigureOut">
               <a:rPr lang="es-ES" smtClean="0"/>
               <a:pPr/>
-              <a:t>23/06/2026</a:t>
+              <a:t>26/06/2026</a:t>
             </a:fld>
             <a:endParaRPr lang="es-ES"/>
           </a:p>
@@ -1334,7 +1335,7 @@
             <a:fld id="{7A847CFC-816F-41D0-AAC0-9BF4FEBC753E}" type="datetimeFigureOut">
               <a:rPr lang="es-ES" smtClean="0"/>
               <a:pPr/>
-              <a:t>23/06/2026</a:t>
+              <a:t>26/06/2026</a:t>
             </a:fld>
             <a:endParaRPr lang="es-ES"/>
           </a:p>
@@ -1753,7 +1754,7 @@
             <a:fld id="{7A847CFC-816F-41D0-AAC0-9BF4FEBC753E}" type="datetimeFigureOut">
               <a:rPr lang="es-ES" smtClean="0"/>
               <a:pPr/>
-              <a:t>23/06/2026</a:t>
+              <a:t>26/06/2026</a:t>
             </a:fld>
             <a:endParaRPr lang="es-ES"/>
           </a:p>
@@ -1868,7 +1869,7 @@
             <a:fld id="{7A847CFC-816F-41D0-AAC0-9BF4FEBC753E}" type="datetimeFigureOut">
               <a:rPr lang="es-ES" smtClean="0"/>
               <a:pPr/>
-              <a:t>23/06/2026</a:t>
+              <a:t>26/06/2026</a:t>
             </a:fld>
             <a:endParaRPr lang="es-ES"/>
           </a:p>
@@ -1960,7 +1961,7 @@
             <a:fld id="{7A847CFC-816F-41D0-AAC0-9BF4FEBC753E}" type="datetimeFigureOut">
               <a:rPr lang="es-ES" smtClean="0"/>
               <a:pPr/>
-              <a:t>23/06/2026</a:t>
+              <a:t>26/06/2026</a:t>
             </a:fld>
             <a:endParaRPr lang="es-ES"/>
           </a:p>
@@ -2234,7 +2235,7 @@
             <a:fld id="{7A847CFC-816F-41D0-AAC0-9BF4FEBC753E}" type="datetimeFigureOut">
               <a:rPr lang="es-ES" smtClean="0"/>
               <a:pPr/>
-              <a:t>23/06/2026</a:t>
+              <a:t>26/06/2026</a:t>
             </a:fld>
             <a:endParaRPr lang="es-ES"/>
           </a:p>
@@ -2484,7 +2485,7 @@
             <a:fld id="{7A847CFC-816F-41D0-AAC0-9BF4FEBC753E}" type="datetimeFigureOut">
               <a:rPr lang="es-ES" smtClean="0"/>
               <a:pPr/>
-              <a:t>23/06/2026</a:t>
+              <a:t>26/06/2026</a:t>
             </a:fld>
             <a:endParaRPr lang="es-ES"/>
           </a:p>
@@ -2694,7 +2695,7 @@
             <a:fld id="{7A847CFC-816F-41D0-AAC0-9BF4FEBC753E}" type="datetimeFigureOut">
               <a:rPr lang="es-ES" smtClean="0"/>
               <a:pPr/>
-              <a:t>23/06/2026</a:t>
+              <a:t>26/06/2026</a:t>
             </a:fld>
             <a:endParaRPr lang="es-ES"/>
           </a:p>
@@ -4951,6 +4952,367 @@
             <a:r>
               <a:rPr lang="es-ES" dirty="0" smtClean="0"/>
               <a:t>JUNIT</a:t>
+            </a:r>
+            <a:endParaRPr lang="es-ES" dirty="0"/>
+          </a:p>
+        </p:txBody>
+      </p:sp>
+    </p:spTree>
+  </p:cSld>
+  <p:clrMapOvr>
+    <a:masterClrMapping/>
+  </p:clrMapOvr>
+</p:sld>
+</file>
+
+<file path=ppt/slides/slide8.xml><?xml version="1.0" encoding="utf-8"?>
+<p:sld xmlns:a="http://schemas.openxmlformats.org/drawingml/2006/main" xmlns:r="http://schemas.openxmlformats.org/officeDocument/2006/relationships" xmlns:p="http://schemas.openxmlformats.org/presentationml/2006/main">
+  <p:cSld>
+    <p:spTree>
+      <p:nvGrpSpPr>
+        <p:cNvPr id="1" name=""/>
+        <p:cNvGrpSpPr/>
+        <p:nvPr/>
+      </p:nvGrpSpPr>
+      <p:grpSpPr>
+        <a:xfrm>
+          <a:off x="0" y="0"/>
+          <a:ext cx="0" cy="0"/>
+          <a:chOff x="0" y="0"/>
+          <a:chExt cx="0" cy="0"/>
+        </a:xfrm>
+      </p:grpSpPr>
+      <p:sp>
+        <p:nvSpPr>
+          <p:cNvPr id="2" name="1 CuadroTexto"/>
+          <p:cNvSpPr txBox="1"/>
+          <p:nvPr/>
+        </p:nvSpPr>
+        <p:spPr>
+          <a:xfrm>
+            <a:off x="1979712" y="620688"/>
+            <a:ext cx="5400600" cy="369332"/>
+          </a:xfrm>
+          <a:prstGeom prst="rect">
+            <a:avLst/>
+          </a:prstGeom>
+          <a:noFill/>
+        </p:spPr>
+        <p:txBody>
+          <a:bodyPr wrap="square" rtlCol="0">
+            <a:spAutoFit/>
+          </a:bodyPr>
+          <a:lstStyle/>
+          <a:p>
+            <a:r>
+              <a:rPr lang="es-ES" dirty="0" smtClean="0"/>
+              <a:t>Acceso a bases de datos en Java</a:t>
+            </a:r>
+            <a:endParaRPr lang="es-ES" dirty="0"/>
+          </a:p>
+        </p:txBody>
+      </p:sp>
+      <p:sp>
+        <p:nvSpPr>
+          <p:cNvPr id="3" name="2 Rectángulo redondeado"/>
+          <p:cNvSpPr/>
+          <p:nvPr/>
+        </p:nvSpPr>
+        <p:spPr>
+          <a:xfrm>
+            <a:off x="971600" y="1700808"/>
+            <a:ext cx="2520280" cy="936104"/>
+          </a:xfrm>
+          <a:prstGeom prst="roundRect">
+            <a:avLst/>
+          </a:prstGeom>
+          <a:noFill/>
+        </p:spPr>
+        <p:style>
+          <a:lnRef idx="2">
+            <a:schemeClr val="accent1">
+              <a:shade val="50000"/>
+            </a:schemeClr>
+          </a:lnRef>
+          <a:fillRef idx="1">
+            <a:schemeClr val="accent1"/>
+          </a:fillRef>
+          <a:effectRef idx="0">
+            <a:schemeClr val="accent1"/>
+          </a:effectRef>
+          <a:fontRef idx="minor">
+            <a:schemeClr val="lt1"/>
+          </a:fontRef>
+        </p:style>
+        <p:txBody>
+          <a:bodyPr rtlCol="0" anchor="ctr"/>
+          <a:lstStyle/>
+          <a:p>
+            <a:pPr algn="ctr"/>
+            <a:endParaRPr lang="es-ES"/>
+          </a:p>
+        </p:txBody>
+      </p:sp>
+      <p:sp>
+        <p:nvSpPr>
+          <p:cNvPr id="4" name="3 CuadroTexto"/>
+          <p:cNvSpPr txBox="1"/>
+          <p:nvPr/>
+        </p:nvSpPr>
+        <p:spPr>
+          <a:xfrm>
+            <a:off x="1547664" y="1916832"/>
+            <a:ext cx="1800200" cy="523220"/>
+          </a:xfrm>
+          <a:prstGeom prst="rect">
+            <a:avLst/>
+          </a:prstGeom>
+          <a:noFill/>
+        </p:spPr>
+        <p:txBody>
+          <a:bodyPr wrap="square" rtlCol="0">
+            <a:spAutoFit/>
+          </a:bodyPr>
+          <a:lstStyle/>
+          <a:p>
+            <a:r>
+              <a:rPr lang="es-ES" sz="2800" dirty="0" smtClean="0"/>
+              <a:t>JDBC</a:t>
+            </a:r>
+            <a:endParaRPr lang="es-ES" sz="2800" dirty="0"/>
+          </a:p>
+        </p:txBody>
+      </p:sp>
+      <p:cxnSp>
+        <p:nvCxnSpPr>
+          <p:cNvPr id="6" name="5 Conector recto de flecha"/>
+          <p:cNvCxnSpPr/>
+          <p:nvPr/>
+        </p:nvCxnSpPr>
+        <p:spPr>
+          <a:xfrm>
+            <a:off x="3635896" y="2204864"/>
+            <a:ext cx="2448272" cy="0"/>
+          </a:xfrm>
+          <a:prstGeom prst="straightConnector1">
+            <a:avLst/>
+          </a:prstGeom>
+          <a:ln>
+            <a:tailEnd type="arrow"/>
+          </a:ln>
+        </p:spPr>
+        <p:style>
+          <a:lnRef idx="1">
+            <a:schemeClr val="accent1"/>
+          </a:lnRef>
+          <a:fillRef idx="0">
+            <a:schemeClr val="accent1"/>
+          </a:fillRef>
+          <a:effectRef idx="0">
+            <a:schemeClr val="accent1"/>
+          </a:effectRef>
+          <a:fontRef idx="minor">
+            <a:schemeClr val="tx1"/>
+          </a:fontRef>
+        </p:style>
+      </p:cxnSp>
+      <p:sp>
+        <p:nvSpPr>
+          <p:cNvPr id="7" name="6 CuadroTexto"/>
+          <p:cNvSpPr txBox="1"/>
+          <p:nvPr/>
+        </p:nvSpPr>
+        <p:spPr>
+          <a:xfrm>
+            <a:off x="3923928" y="1772816"/>
+            <a:ext cx="3384376" cy="369332"/>
+          </a:xfrm>
+          <a:prstGeom prst="rect">
+            <a:avLst/>
+          </a:prstGeom>
+          <a:noFill/>
+        </p:spPr>
+        <p:txBody>
+          <a:bodyPr wrap="square" rtlCol="0">
+            <a:spAutoFit/>
+          </a:bodyPr>
+          <a:lstStyle/>
+          <a:p>
+            <a:r>
+              <a:rPr lang="es-ES" dirty="0" smtClean="0"/>
+              <a:t>acceso directo a tablas con SQL</a:t>
+            </a:r>
+            <a:endParaRPr lang="es-ES" dirty="0"/>
+          </a:p>
+        </p:txBody>
+      </p:sp>
+      <p:sp>
+        <p:nvSpPr>
+          <p:cNvPr id="8" name="7 Rectángulo redondeado"/>
+          <p:cNvSpPr/>
+          <p:nvPr/>
+        </p:nvSpPr>
+        <p:spPr>
+          <a:xfrm>
+            <a:off x="971600" y="3789040"/>
+            <a:ext cx="2520280" cy="936104"/>
+          </a:xfrm>
+          <a:prstGeom prst="roundRect">
+            <a:avLst/>
+          </a:prstGeom>
+          <a:noFill/>
+        </p:spPr>
+        <p:style>
+          <a:lnRef idx="2">
+            <a:schemeClr val="accent1">
+              <a:shade val="50000"/>
+            </a:schemeClr>
+          </a:lnRef>
+          <a:fillRef idx="1">
+            <a:schemeClr val="accent1"/>
+          </a:fillRef>
+          <a:effectRef idx="0">
+            <a:schemeClr val="accent1"/>
+          </a:effectRef>
+          <a:fontRef idx="minor">
+            <a:schemeClr val="lt1"/>
+          </a:fontRef>
+        </p:style>
+        <p:txBody>
+          <a:bodyPr rtlCol="0" anchor="ctr"/>
+          <a:lstStyle/>
+          <a:p>
+            <a:pPr algn="ctr"/>
+            <a:endParaRPr lang="es-ES"/>
+          </a:p>
+        </p:txBody>
+      </p:sp>
+      <p:sp>
+        <p:nvSpPr>
+          <p:cNvPr id="9" name="8 CuadroTexto"/>
+          <p:cNvSpPr txBox="1"/>
+          <p:nvPr/>
+        </p:nvSpPr>
+        <p:spPr>
+          <a:xfrm>
+            <a:off x="1547664" y="4005064"/>
+            <a:ext cx="1800200" cy="523220"/>
+          </a:xfrm>
+          <a:prstGeom prst="rect">
+            <a:avLst/>
+          </a:prstGeom>
+          <a:noFill/>
+        </p:spPr>
+        <p:txBody>
+          <a:bodyPr wrap="square" rtlCol="0">
+            <a:spAutoFit/>
+          </a:bodyPr>
+          <a:lstStyle/>
+          <a:p>
+            <a:r>
+              <a:rPr lang="es-ES" sz="2800" dirty="0" smtClean="0"/>
+              <a:t>JPA</a:t>
+            </a:r>
+            <a:endParaRPr lang="es-ES" sz="2800" dirty="0"/>
+          </a:p>
+        </p:txBody>
+      </p:sp>
+      <p:cxnSp>
+        <p:nvCxnSpPr>
+          <p:cNvPr id="10" name="9 Conector recto de flecha"/>
+          <p:cNvCxnSpPr/>
+          <p:nvPr/>
+        </p:nvCxnSpPr>
+        <p:spPr>
+          <a:xfrm>
+            <a:off x="3635896" y="4293096"/>
+            <a:ext cx="2448272" cy="0"/>
+          </a:xfrm>
+          <a:prstGeom prst="straightConnector1">
+            <a:avLst/>
+          </a:prstGeom>
+          <a:ln>
+            <a:tailEnd type="arrow"/>
+          </a:ln>
+        </p:spPr>
+        <p:style>
+          <a:lnRef idx="1">
+            <a:schemeClr val="accent1"/>
+          </a:lnRef>
+          <a:fillRef idx="0">
+            <a:schemeClr val="accent1"/>
+          </a:fillRef>
+          <a:effectRef idx="0">
+            <a:schemeClr val="accent1"/>
+          </a:effectRef>
+          <a:fontRef idx="minor">
+            <a:schemeClr val="tx1"/>
+          </a:fontRef>
+        </p:style>
+      </p:cxnSp>
+      <p:sp>
+        <p:nvSpPr>
+          <p:cNvPr id="11" name="10 CuadroTexto"/>
+          <p:cNvSpPr txBox="1"/>
+          <p:nvPr/>
+        </p:nvSpPr>
+        <p:spPr>
+          <a:xfrm>
+            <a:off x="3923928" y="3861048"/>
+            <a:ext cx="4536504" cy="369332"/>
+          </a:xfrm>
+          <a:prstGeom prst="rect">
+            <a:avLst/>
+          </a:prstGeom>
+          <a:noFill/>
+        </p:spPr>
+        <p:txBody>
+          <a:bodyPr wrap="square" rtlCol="0">
+            <a:spAutoFit/>
+          </a:bodyPr>
+          <a:lstStyle/>
+          <a:p>
+            <a:r>
+              <a:rPr lang="es-ES" dirty="0" smtClean="0"/>
+              <a:t>acceso a través de capa de persistencia</a:t>
+            </a:r>
+            <a:endParaRPr lang="es-ES" dirty="0"/>
+          </a:p>
+        </p:txBody>
+      </p:sp>
+      <p:sp>
+        <p:nvSpPr>
+          <p:cNvPr id="12" name="11 CuadroTexto"/>
+          <p:cNvSpPr txBox="1"/>
+          <p:nvPr/>
+        </p:nvSpPr>
+        <p:spPr>
+          <a:xfrm>
+            <a:off x="4211960" y="4581128"/>
+            <a:ext cx="4752528" cy="369332"/>
+          </a:xfrm>
+          <a:prstGeom prst="rect">
+            <a:avLst/>
+          </a:prstGeom>
+          <a:noFill/>
+        </p:spPr>
+        <p:txBody>
+          <a:bodyPr wrap="square" rtlCol="0">
+            <a:spAutoFit/>
+          </a:bodyPr>
+          <a:lstStyle/>
+          <a:p>
+            <a:r>
+              <a:rPr lang="es-ES" dirty="0" smtClean="0"/>
+              <a:t>Framework de persistencia (</a:t>
+            </a:r>
+            <a:r>
+              <a:rPr lang="es-ES" dirty="0" err="1" smtClean="0"/>
+              <a:t>hibernate</a:t>
+            </a:r>
+            <a:r>
+              <a:rPr lang="es-ES" dirty="0" smtClean="0"/>
+              <a:t>)</a:t>
             </a:r>
             <a:endParaRPr lang="es-ES" dirty="0"/>
           </a:p>

</xml_diff>